<commit_message>
fix: t3 slide3 - resize idx=1 placeholder in template file directly
</commit_message>
<xml_diff>
--- a/templates/shablonlar/3.pptx
+++ b/templates/shablonlar/3.pptx
@@ -7462,8 +7462,8 @@
         </p:nvSpPr>
         <p:spPr>
           <a:xfrm>
-            <a:off x="1235869" y="1942050"/>
-            <a:ext cx="6593681" cy="1683900"/>
+            <a:off x="1234440" y="1371600"/>
+            <a:ext cx="6675120" cy="3383280"/>
           </a:xfrm>
           <a:prstGeom prst="rect">
             <a:avLst/>

</xml_diff>